<commit_message>
Add OR/simulation policy-lever counterfactual and strengthen Healthcare Analytics framing
- data_primary/build_reanalysis.py: add policy_simulation() projecting 2034 physician counts under litigation-elimination (point and 95% lower-bound) and an MDE-benchmark lever.
- manuscript/build_figures_en.py: add plot_policy_simulation() and generate Figure 6 / ha_Figure_3.png.
- manuscript/build_healthcare_analytics_submission.py: add Methods/Results subsections for the policy-lever simulation, update cover letter, title page counts (3 main figures), and zip/pptx lists.
- Regenerate all ha_* submission artifacts and reanalysis_results.json.

Refs: PR #348
Co-Authored-By: Tatsuki Onishi <bougtoir@gmail.com>
</commit_message>
<xml_diff>
--- a/medical_accident_its_analysis/manuscript/ha_figures.pptx
+++ b/medical_accident_its_analysis/manuscript/ha_figures.pptx
@@ -7,6 +7,7 @@
   <p:sldIdLst>
     <p:sldId id="256" r:id="rId7"/>
     <p:sldId id="257" r:id="rId8"/>
+    <p:sldId id="258" r:id="rId9"/>
   </p:sldIdLst>
   <p:sldSz cx="12191695" cy="6858000" type="screen4x3"/>
   <p:notesSz cx="6858000" cy="9144000"/>
@@ -3267,6 +3268,106 @@
             <a:r>
               <a:rPr sz="1400"/>
               <a:t>Biennial physician growth against lagged litigation exposure measured as (a) counts and (b) rates. Points are coloured by specialty; the count panel shows the size confounding that the rate panel removes.</a:t>
+            </a:r>
+          </a:p>
+        </p:txBody>
+      </p:sp>
+    </p:spTree>
+  </p:cSld>
+  <p:clrMapOvr>
+    <a:masterClrMapping/>
+  </p:clrMapOvr>
+</p:sld>
+</file>
+
+<file path=ppt/slides/slide3.xml><?xml version="1.0" encoding="utf-8"?>
+<p:sld xmlns:a="http://schemas.openxmlformats.org/drawingml/2006/main" xmlns:p="http://schemas.openxmlformats.org/presentationml/2006/main" xmlns:r="http://schemas.openxmlformats.org/officeDocument/2006/relationships">
+  <p:cSld>
+    <p:spTree>
+      <p:nvGrpSpPr>
+        <p:cNvPr id="1" name=""/>
+        <p:cNvGrpSpPr/>
+        <p:nvPr/>
+      </p:nvGrpSpPr>
+      <p:grpSpPr/>
+      <p:sp>
+        <p:nvSpPr>
+          <p:cNvPr id="2" name="TextBox 1"/>
+          <p:cNvSpPr txBox="1"/>
+          <p:nvPr/>
+        </p:nvSpPr>
+        <p:spPr>
+          <a:xfrm>
+            <a:off x="457200" y="182880"/>
+            <a:ext cx="11247120" cy="640080"/>
+          </a:xfrm>
+          <a:prstGeom prst="rect">
+            <a:avLst/>
+          </a:prstGeom>
+          <a:noFill/>
+        </p:spPr>
+        <p:txBody>
+          <a:bodyPr wrap="none">
+            <a:spAutoFit/>
+          </a:bodyPr>
+          <a:lstStyle/>
+          <a:p>
+            <a:r>
+              <a:rPr sz="2400" b="1"/>
+              <a:t>Figure 3</a:t>
+            </a:r>
+          </a:p>
+        </p:txBody>
+      </p:sp>
+      <p:pic>
+        <p:nvPicPr>
+          <p:cNvPr id="3" name="Picture 2" descr="ha_Figure_3.png"/>
+          <p:cNvPicPr>
+            <a:picLocks noChangeAspect="1"/>
+          </p:cNvPicPr>
+          <p:nvPr/>
+        </p:nvPicPr>
+        <p:blipFill>
+          <a:blip r:embed="rId2"/>
+          <a:stretch>
+            <a:fillRect/>
+          </a:stretch>
+        </p:blipFill>
+        <p:spPr>
+          <a:xfrm>
+            <a:off x="1097280" y="1005840"/>
+            <a:ext cx="10460736" cy="4754880"/>
+          </a:xfrm>
+          <a:prstGeom prst="rect">
+            <a:avLst/>
+          </a:prstGeom>
+        </p:spPr>
+      </p:pic>
+      <p:sp>
+        <p:nvSpPr>
+          <p:cNvPr id="4" name="TextBox 3"/>
+          <p:cNvSpPr txBox="1"/>
+          <p:nvPr/>
+        </p:nvSpPr>
+        <p:spPr>
+          <a:xfrm>
+            <a:off x="457200" y="5943600"/>
+            <a:ext cx="11247120" cy="822960"/>
+          </a:xfrm>
+          <a:prstGeom prst="rect">
+            <a:avLst/>
+          </a:prstGeom>
+          <a:noFill/>
+        </p:spPr>
+        <p:txBody>
+          <a:bodyPr wrap="square">
+            <a:spAutoFit/>
+          </a:bodyPr>
+          <a:lstStyle/>
+          <a:p>
+            <a:r>
+              <a:rPr sz="1400"/>
+              <a:t>Counterfactual policy-lever simulation: marginal 10-year change in physician counts by specialty relative to the projected baseline drift. The MDE benchmark is the minimum detectable per-SD effect from the primary analysis.</a:t>
             </a:r>
           </a:p>
         </p:txBody>

</xml_diff>

<commit_message>
Add hospital count-vs-rate figure, policy simulation table, and clarify specialty count
- Rename N_SPEC -> N_SPECIALTIES (12 core clinical specialties) for clarity.
- manuscript/build_figures_en.py: add plot_hospital_counts_vs_rates(); regenerate ha_Figure_3 (hospital) and ha_Figure_4 (policy simulation).
- manuscript/build_healthcare_analytics_submission.py: add Figure 3 (hospital counts vs rates), Table 3 (counterfactual 2034 physician counts by lever), and renumber policy simulation to Figure 4. Update title page counts and zip/pptx lists.
- Regenerate all submission artifacts from primary data.

Refs: PR follow-up after #348
Co-Authored-By: Tatsuki Onishi <bougtoir@gmail.com>
</commit_message>
<xml_diff>
--- a/medical_accident_its_analysis/manuscript/ha_figures.pptx
+++ b/medical_accident_its_analysis/manuscript/ha_figures.pptx
@@ -8,6 +8,7 @@
     <p:sldId id="256" r:id="rId7"/>
     <p:sldId id="257" r:id="rId8"/>
     <p:sldId id="258" r:id="rId9"/>
+    <p:sldId id="259" r:id="rId10"/>
   </p:sldIdLst>
   <p:sldSz cx="12191695" cy="6858000" type="screen4x3"/>
   <p:notesSz cx="6858000" cy="9144000"/>
@@ -3322,6 +3323,106 @@
       <p:pic>
         <p:nvPicPr>
           <p:cNvPr id="3" name="Picture 2" descr="ha_Figure_3.png"/>
+          <p:cNvPicPr>
+            <a:picLocks noChangeAspect="1"/>
+          </p:cNvPicPr>
+          <p:nvPr/>
+        </p:nvPicPr>
+        <p:blipFill>
+          <a:blip r:embed="rId2"/>
+          <a:stretch>
+            <a:fillRect/>
+          </a:stretch>
+        </p:blipFill>
+        <p:spPr>
+          <a:xfrm>
+            <a:off x="1097280" y="1005840"/>
+            <a:ext cx="10460736" cy="4754880"/>
+          </a:xfrm>
+          <a:prstGeom prst="rect">
+            <a:avLst/>
+          </a:prstGeom>
+        </p:spPr>
+      </p:pic>
+      <p:sp>
+        <p:nvSpPr>
+          <p:cNvPr id="4" name="TextBox 3"/>
+          <p:cNvSpPr txBox="1"/>
+          <p:nvPr/>
+        </p:nvSpPr>
+        <p:spPr>
+          <a:xfrm>
+            <a:off x="457200" y="5943600"/>
+            <a:ext cx="11247120" cy="822960"/>
+          </a:xfrm>
+          <a:prstGeom prst="rect">
+            <a:avLst/>
+          </a:prstGeom>
+          <a:noFill/>
+        </p:spPr>
+        <p:txBody>
+          <a:bodyPr wrap="square">
+            <a:spAutoFit/>
+          </a:bodyPr>
+          <a:lstStyle/>
+          <a:p>
+            <a:r>
+              <a:rPr sz="1400"/>
+              <a:t>Biennial hospital growth against lagged litigation exposure measured as (a) counts and (b) rates. Points are coloured by specialty; the rate-adjusted panel shows no systematic association.</a:t>
+            </a:r>
+          </a:p>
+        </p:txBody>
+      </p:sp>
+    </p:spTree>
+  </p:cSld>
+  <p:clrMapOvr>
+    <a:masterClrMapping/>
+  </p:clrMapOvr>
+</p:sld>
+</file>
+
+<file path=ppt/slides/slide4.xml><?xml version="1.0" encoding="utf-8"?>
+<p:sld xmlns:a="http://schemas.openxmlformats.org/drawingml/2006/main" xmlns:p="http://schemas.openxmlformats.org/presentationml/2006/main" xmlns:r="http://schemas.openxmlformats.org/officeDocument/2006/relationships">
+  <p:cSld>
+    <p:spTree>
+      <p:nvGrpSpPr>
+        <p:cNvPr id="1" name=""/>
+        <p:cNvGrpSpPr/>
+        <p:nvPr/>
+      </p:nvGrpSpPr>
+      <p:grpSpPr/>
+      <p:sp>
+        <p:nvSpPr>
+          <p:cNvPr id="2" name="TextBox 1"/>
+          <p:cNvSpPr txBox="1"/>
+          <p:nvPr/>
+        </p:nvSpPr>
+        <p:spPr>
+          <a:xfrm>
+            <a:off x="457200" y="182880"/>
+            <a:ext cx="11247120" cy="640080"/>
+          </a:xfrm>
+          <a:prstGeom prst="rect">
+            <a:avLst/>
+          </a:prstGeom>
+          <a:noFill/>
+        </p:spPr>
+        <p:txBody>
+          <a:bodyPr wrap="none">
+            <a:spAutoFit/>
+          </a:bodyPr>
+          <a:lstStyle/>
+          <a:p>
+            <a:r>
+              <a:rPr sz="2400" b="1"/>
+              <a:t>Figure 4</a:t>
+            </a:r>
+          </a:p>
+        </p:txBody>
+      </p:sp>
+      <p:pic>
+        <p:nvPicPr>
+          <p:cNvPr id="3" name="Picture 2" descr="ha_Figure_4.png"/>
           <p:cNvPicPr>
             <a:picLocks noChangeAspect="1"/>
           </p:cNvPicPr>

</xml_diff>